<commit_message>
docs: add detailed system and AWS architecture document and diagrams
</commit_message>
<xml_diff>
--- a/docs/CloudMonitor_Cloud_Computing_Mini_Project_.pptx
+++ b/docs/CloudMonitor_Cloud_Computing_Mini_Project_.pptx
@@ -1974,7 +1974,7 @@
             <a:fld id="{5586B75A-687E-405C-8A0B-8D00578BA2C3}" type="datetimeFigureOut">
               <a:rPr lang="en-US" smtClean="0"/>
               <a:pPr/>
-              <a:t>10/28/2026</a:t>
+              <a:t>10/29/2026</a:t>
             </a:fld>
             <a:endParaRPr lang="en-US" dirty="0"/>
           </a:p>
@@ -2248,7 +2248,7 @@
             <a:fld id="{5586B75A-687E-405C-8A0B-8D00578BA2C3}" type="datetimeFigureOut">
               <a:rPr lang="en-US" smtClean="0"/>
               <a:pPr/>
-              <a:t>10/28/2026</a:t>
+              <a:t>10/29/2026</a:t>
             </a:fld>
             <a:endParaRPr lang="en-US" dirty="0"/>
           </a:p>
@@ -2445,7 +2445,7 @@
             <a:fld id="{5586B75A-687E-405C-8A0B-8D00578BA2C3}" type="datetimeFigureOut">
               <a:rPr lang="en-US" smtClean="0"/>
               <a:pPr/>
-              <a:t>10/28/2026</a:t>
+              <a:t>10/29/2026</a:t>
             </a:fld>
             <a:endParaRPr lang="en-US" dirty="0"/>
           </a:p>
@@ -2721,7 +2721,7 @@
             <a:fld id="{5586B75A-687E-405C-8A0B-8D00578BA2C3}" type="datetimeFigureOut">
               <a:rPr lang="en-US" smtClean="0"/>
               <a:pPr/>
-              <a:t>10/28/2026</a:t>
+              <a:t>10/29/2026</a:t>
             </a:fld>
             <a:endParaRPr lang="en-US" dirty="0"/>
           </a:p>
@@ -3065,7 +3065,7 @@
             <a:fld id="{5586B75A-687E-405C-8A0B-8D00578BA2C3}" type="datetimeFigureOut">
               <a:rPr lang="en-US" smtClean="0"/>
               <a:pPr/>
-              <a:t>10/28/2026</a:t>
+              <a:t>10/29/2026</a:t>
             </a:fld>
             <a:endParaRPr lang="en-US" dirty="0"/>
           </a:p>
@@ -3691,7 +3691,7 @@
             <a:fld id="{5586B75A-687E-405C-8A0B-8D00578BA2C3}" type="datetimeFigureOut">
               <a:rPr lang="en-US" smtClean="0"/>
               <a:pPr/>
-              <a:t>10/28/2026</a:t>
+              <a:t>10/29/2026</a:t>
             </a:fld>
             <a:endParaRPr lang="en-US" dirty="0"/>
           </a:p>
@@ -4542,7 +4542,7 @@
             <a:fld id="{5586B75A-687E-405C-8A0B-8D00578BA2C3}" type="datetimeFigureOut">
               <a:rPr lang="en-US" smtClean="0"/>
               <a:pPr/>
-              <a:t>10/28/2026</a:t>
+              <a:t>10/29/2026</a:t>
             </a:fld>
             <a:endParaRPr lang="en-US" dirty="0"/>
           </a:p>
@@ -4715,7 +4715,7 @@
             <a:fld id="{5586B75A-687E-405C-8A0B-8D00578BA2C3}" type="datetimeFigureOut">
               <a:rPr lang="en-US" smtClean="0"/>
               <a:pPr/>
-              <a:t>10/28/2026</a:t>
+              <a:t>10/29/2026</a:t>
             </a:fld>
             <a:endParaRPr lang="en-US" dirty="0"/>
           </a:p>
@@ -4898,7 +4898,7 @@
             <a:fld id="{5586B75A-687E-405C-8A0B-8D00578BA2C3}" type="datetimeFigureOut">
               <a:rPr lang="en-US" smtClean="0"/>
               <a:pPr/>
-              <a:t>10/28/2026</a:t>
+              <a:t>10/29/2026</a:t>
             </a:fld>
             <a:endParaRPr lang="en-US" dirty="0"/>
           </a:p>
@@ -5126,7 +5126,7 @@
           </a:prstGeom>
           <a:extLst>
             <a:ext uri="{C572A759-6A51-4108-AA02-DFA0A04FC94B}">
-              <ma14:wrappingTextBoxFlag xmlns:ma14="http://schemas.microsoft.com/office/mac/drawingml/2011/main" xmlns="" val="0"/>
+              <ma14:wrappingTextBoxFlag xmlns="" xmlns:ma14="http://schemas.microsoft.com/office/mac/drawingml/2011/main" val="0"/>
             </a:ext>
           </a:extLst>
         </p:spPr>
@@ -5274,7 +5274,7 @@
             <a:fld id="{5586B75A-687E-405C-8A0B-8D00578BA2C3}" type="datetimeFigureOut">
               <a:rPr lang="en-US" smtClean="0"/>
               <a:pPr/>
-              <a:t>10/28/2026</a:t>
+              <a:t>10/29/2026</a:t>
             </a:fld>
             <a:endParaRPr lang="en-US" dirty="0"/>
           </a:p>
@@ -5524,7 +5524,7 @@
             <a:fld id="{5586B75A-687E-405C-8A0B-8D00578BA2C3}" type="datetimeFigureOut">
               <a:rPr lang="en-US" smtClean="0"/>
               <a:pPr/>
-              <a:t>10/28/2026</a:t>
+              <a:t>10/29/2026</a:t>
             </a:fld>
             <a:endParaRPr lang="en-US" dirty="0"/>
           </a:p>
@@ -5819,7 +5819,7 @@
             <a:fld id="{5586B75A-687E-405C-8A0B-8D00578BA2C3}" type="datetimeFigureOut">
               <a:rPr lang="en-US" smtClean="0"/>
               <a:pPr/>
-              <a:t>10/28/2026</a:t>
+              <a:t>10/29/2026</a:t>
             </a:fld>
             <a:endParaRPr lang="en-US" dirty="0"/>
           </a:p>
@@ -6266,7 +6266,7 @@
             <a:fld id="{5586B75A-687E-405C-8A0B-8D00578BA2C3}" type="datetimeFigureOut">
               <a:rPr lang="en-US" smtClean="0"/>
               <a:pPr/>
-              <a:t>10/28/2026</a:t>
+              <a:t>10/29/2026</a:t>
             </a:fld>
             <a:endParaRPr lang="en-US" dirty="0"/>
           </a:p>
@@ -6387,7 +6387,7 @@
             <a:fld id="{5586B75A-687E-405C-8A0B-8D00578BA2C3}" type="datetimeFigureOut">
               <a:rPr lang="en-US" smtClean="0"/>
               <a:pPr/>
-              <a:t>10/28/2026</a:t>
+              <a:t>10/29/2026</a:t>
             </a:fld>
             <a:endParaRPr lang="en-US" dirty="0"/>
           </a:p>
@@ -6485,7 +6485,7 @@
             <a:fld id="{5586B75A-687E-405C-8A0B-8D00578BA2C3}" type="datetimeFigureOut">
               <a:rPr lang="en-US" smtClean="0"/>
               <a:pPr/>
-              <a:t>10/28/2026</a:t>
+              <a:t>10/29/2026</a:t>
             </a:fld>
             <a:endParaRPr lang="en-US" dirty="0"/>
           </a:p>
@@ -6767,7 +6767,7 @@
             <a:fld id="{5586B75A-687E-405C-8A0B-8D00578BA2C3}" type="datetimeFigureOut">
               <a:rPr lang="en-US" smtClean="0"/>
               <a:pPr/>
-              <a:t>10/28/2026</a:t>
+              <a:t>10/29/2026</a:t>
             </a:fld>
             <a:endParaRPr lang="en-US" dirty="0"/>
           </a:p>
@@ -7041,7 +7041,7 @@
             <a:fld id="{5586B75A-687E-405C-8A0B-8D00578BA2C3}" type="datetimeFigureOut">
               <a:rPr lang="en-US" smtClean="0"/>
               <a:pPr/>
-              <a:t>10/28/2026</a:t>
+              <a:t>10/29/2026</a:t>
             </a:fld>
             <a:endParaRPr lang="en-US" dirty="0"/>
           </a:p>
@@ -7483,7 +7483,7 @@
             <a:fld id="{5586B75A-687E-405C-8A0B-8D00578BA2C3}" type="datetimeFigureOut">
               <a:rPr lang="en-US" smtClean="0"/>
               <a:pPr/>
-              <a:t>10/28/2026</a:t>
+              <a:t>10/29/2026</a:t>
             </a:fld>
             <a:endParaRPr lang="en-US" dirty="0"/>
           </a:p>
@@ -8820,7 +8820,7 @@
           </a:prstGeom>
           <a:extLst>
             <a:ext uri="{C572A759-6A51-4108-AA02-DFA0A04FC94B}">
-              <ma14:wrappingTextBoxFlag xmlns:ma14="http://schemas.microsoft.com/office/mac/drawingml/2011/main" xmlns="" val="0"/>
+              <ma14:wrappingTextBoxFlag xmlns="" xmlns:ma14="http://schemas.microsoft.com/office/mac/drawingml/2011/main" val="0"/>
             </a:ext>
           </a:extLst>
         </p:spPr>
@@ -8898,64 +8898,6 @@
               <a:rPr lang="en-US" dirty="0"/>
               <a:t>10. Security &amp; Cost Considerations</a:t>
             </a:r>
-          </a:p>
-        </p:txBody>
-      </p:sp>
-      <p:sp>
-        <p:nvSpPr>
-          <p:cNvPr id="3" name="Shape 1"/>
-          <p:cNvSpPr/>
-          <p:nvPr/>
-        </p:nvSpPr>
-        <p:spPr>
-          <a:xfrm>
-            <a:off x="5943600" y="4754880"/>
-            <a:ext cx="2194560" cy="274320"/>
-          </a:xfrm>
-          <a:prstGeom prst="roundRect">
-            <a:avLst>
-              <a:gd name="adj" fmla="val 20000"/>
-            </a:avLst>
-          </a:prstGeom>
-          <a:solidFill>
-            <a:schemeClr val="accent2"/>
-          </a:solidFill>
-          <a:ln/>
-        </p:spPr>
-      </p:sp>
-      <p:sp>
-        <p:nvSpPr>
-          <p:cNvPr id="4" name="Text 2"/>
-          <p:cNvSpPr txBox="1"/>
-          <p:nvPr/>
-        </p:nvSpPr>
-        <p:spPr>
-          <a:xfrm>
-            <a:off x="5943600" y="4754880"/>
-            <a:ext cx="2194560" cy="274320"/>
-          </a:xfrm>
-          <a:prstGeom prst="rect">
-            <a:avLst/>
-          </a:prstGeom>
-          <a:noFill/>
-          <a:ln/>
-        </p:spPr>
-        <p:txBody>
-          <a:bodyPr wrap="square" lIns="0" tIns="0" rIns="0" bIns="0" rtlCol="0" anchor="ctr"/>
-          <a:lstStyle/>
-          <a:p>
-            <a:pPr marL="0" indent="0" algn="ctr">
-              <a:buNone/>
-            </a:pPr>
-            <a:r>
-              <a:rPr lang="en-US" sz="1000" b="1" dirty="0">
-                <a:solidFill>
-                  <a:schemeClr val="tx2"/>
-                </a:solidFill>
-              </a:rPr>
-              <a:t>SAMPLE DATA: replace with real</a:t>
-            </a:r>
-            <a:endParaRPr lang="en-US" sz="1000" dirty="0"/>
           </a:p>
         </p:txBody>
       </p:sp>
@@ -10229,7 +10171,7 @@
           </a:prstGeom>
           <a:extLst>
             <a:ext uri="{C572A759-6A51-4108-AA02-DFA0A04FC94B}">
-              <ma14:wrappingTextBoxFlag xmlns:ma14="http://schemas.microsoft.com/office/mac/drawingml/2011/main" xmlns="" val="0"/>
+              <ma14:wrappingTextBoxFlag xmlns="" xmlns:ma14="http://schemas.microsoft.com/office/mac/drawingml/2011/main" val="0"/>
             </a:ext>
           </a:extLst>
         </p:spPr>
@@ -10612,7 +10554,7 @@
           </a:prstGeom>
           <a:extLst>
             <a:ext uri="{C572A759-6A51-4108-AA02-DFA0A04FC94B}">
-              <ma14:wrappingTextBoxFlag xmlns:ma14="http://schemas.microsoft.com/office/mac/drawingml/2011/main" xmlns="" val="0"/>
+              <ma14:wrappingTextBoxFlag xmlns="" xmlns:ma14="http://schemas.microsoft.com/office/mac/drawingml/2011/main" val="0"/>
             </a:ext>
           </a:extLst>
         </p:spPr>
@@ -12089,7 +12031,7 @@
           </a:prstGeom>
           <a:extLst>
             <a:ext uri="{C572A759-6A51-4108-AA02-DFA0A04FC94B}">
-              <ma14:wrappingTextBoxFlag xmlns:ma14="http://schemas.microsoft.com/office/mac/drawingml/2011/main" xmlns="" val="0"/>
+              <ma14:wrappingTextBoxFlag xmlns="" xmlns:ma14="http://schemas.microsoft.com/office/mac/drawingml/2011/main" val="0"/>
             </a:ext>
           </a:extLst>
         </p:spPr>
@@ -13062,7 +13004,7 @@
           </a:prstGeom>
           <a:extLst>
             <a:ext uri="{C572A759-6A51-4108-AA02-DFA0A04FC94B}">
-              <ma14:wrappingTextBoxFlag xmlns:ma14="http://schemas.microsoft.com/office/mac/drawingml/2011/main" xmlns="" val="0"/>
+              <ma14:wrappingTextBoxFlag xmlns="" xmlns:ma14="http://schemas.microsoft.com/office/mac/drawingml/2011/main" val="0"/>
             </a:ext>
           </a:extLst>
         </p:spPr>
@@ -13619,7 +13561,7 @@
           </a:prstGeom>
           <a:extLst>
             <a:ext uri="{C572A759-6A51-4108-AA02-DFA0A04FC94B}">
-              <ma14:wrappingTextBoxFlag xmlns:ma14="http://schemas.microsoft.com/office/mac/drawingml/2011/main" xmlns="" val="0"/>
+              <ma14:wrappingTextBoxFlag xmlns="" xmlns:ma14="http://schemas.microsoft.com/office/mac/drawingml/2011/main" val="0"/>
             </a:ext>
           </a:extLst>
         </p:spPr>
@@ -14311,7 +14253,7 @@
           </a:prstGeom>
           <a:extLst>
             <a:ext uri="{C572A759-6A51-4108-AA02-DFA0A04FC94B}">
-              <ma14:wrappingTextBoxFlag xmlns:ma14="http://schemas.microsoft.com/office/mac/drawingml/2011/main" xmlns="" val="0"/>
+              <ma14:wrappingTextBoxFlag xmlns="" xmlns:ma14="http://schemas.microsoft.com/office/mac/drawingml/2011/main" val="0"/>
             </a:ext>
           </a:extLst>
         </p:spPr>
@@ -14874,7 +14816,7 @@
           </a:prstGeom>
           <a:extLst>
             <a:ext uri="{C572A759-6A51-4108-AA02-DFA0A04FC94B}">
-              <ma14:wrappingTextBoxFlag xmlns:ma14="http://schemas.microsoft.com/office/mac/drawingml/2011/main" xmlns="" val="0"/>
+              <ma14:wrappingTextBoxFlag xmlns="" xmlns:ma14="http://schemas.microsoft.com/office/mac/drawingml/2011/main" val="0"/>
             </a:ext>
           </a:extLst>
         </p:spPr>
@@ -15793,7 +15735,7 @@
           </a:prstGeom>
           <a:extLst>
             <a:ext uri="{C572A759-6A51-4108-AA02-DFA0A04FC94B}">
-              <ma14:wrappingTextBoxFlag xmlns:ma14="http://schemas.microsoft.com/office/mac/drawingml/2011/main" xmlns="" val="0"/>
+              <ma14:wrappingTextBoxFlag xmlns="" xmlns:ma14="http://schemas.microsoft.com/office/mac/drawingml/2011/main" val="0"/>
             </a:ext>
           </a:extLst>
         </p:spPr>
@@ -16854,7 +16796,7 @@
           </a:prstGeom>
           <a:extLst>
             <a:ext uri="{C572A759-6A51-4108-AA02-DFA0A04FC94B}">
-              <ma14:wrappingTextBoxFlag xmlns:ma14="http://schemas.microsoft.com/office/mac/drawingml/2011/main" xmlns="" val="0"/>
+              <ma14:wrappingTextBoxFlag xmlns="" xmlns:ma14="http://schemas.microsoft.com/office/mac/drawingml/2011/main" val="0"/>
             </a:ext>
           </a:extLst>
         </p:spPr>
@@ -17331,7 +17273,7 @@
           </a:prstGeom>
           <a:extLst>
             <a:ext uri="{C572A759-6A51-4108-AA02-DFA0A04FC94B}">
-              <ma14:wrappingTextBoxFlag xmlns:ma14="http://schemas.microsoft.com/office/mac/drawingml/2011/main" xmlns="" val="0"/>
+              <ma14:wrappingTextBoxFlag xmlns="" xmlns:ma14="http://schemas.microsoft.com/office/mac/drawingml/2011/main" val="0"/>
             </a:ext>
           </a:extLst>
         </p:spPr>
@@ -18286,7 +18228,7 @@
           </a:prstGeom>
           <a:extLst>
             <a:ext uri="{C572A759-6A51-4108-AA02-DFA0A04FC94B}">
-              <ma14:wrappingTextBoxFlag xmlns:ma14="http://schemas.microsoft.com/office/mac/drawingml/2011/main" xmlns="" val="0"/>
+              <ma14:wrappingTextBoxFlag xmlns="" xmlns:ma14="http://schemas.microsoft.com/office/mac/drawingml/2011/main" val="0"/>
             </a:ext>
           </a:extLst>
         </p:spPr>
@@ -19069,7 +19011,7 @@
           </a:prstGeom>
           <a:extLst>
             <a:ext uri="{C572A759-6A51-4108-AA02-DFA0A04FC94B}">
-              <ma14:wrappingTextBoxFlag xmlns:ma14="http://schemas.microsoft.com/office/mac/drawingml/2011/main" xmlns="" val="0"/>
+              <ma14:wrappingTextBoxFlag xmlns="" xmlns:ma14="http://schemas.microsoft.com/office/mac/drawingml/2011/main" val="0"/>
             </a:ext>
           </a:extLst>
         </p:spPr>
@@ -19916,7 +19858,7 @@
           </a:prstGeom>
           <a:extLst>
             <a:ext uri="{C572A759-6A51-4108-AA02-DFA0A04FC94B}">
-              <ma14:wrappingTextBoxFlag xmlns:ma14="http://schemas.microsoft.com/office/mac/drawingml/2011/main" xmlns="" val="0"/>
+              <ma14:wrappingTextBoxFlag xmlns="" xmlns:ma14="http://schemas.microsoft.com/office/mac/drawingml/2011/main" val="0"/>
             </a:ext>
           </a:extLst>
         </p:spPr>

</xml_diff>